<commit_message>
feat: add Google Colab 1-click execution support and update Slide 12 in presentation deck
</commit_message>
<xml_diff>
--- a/docs/VOIS_Major_Project_Final_Submission.pptx
+++ b/docs/VOIS_Major_Project_Final_Submission.pptx
@@ -4454,7 +4454,7 @@
               </a:defRPr>
             </a:pPr>
             <a:r>
-              <a:t>Project Repository &amp; Code Deliverables</a:t>
+              <a:t>Project Repository &amp; Google Colab Interactive Links</a:t>
             </a:r>
           </a:p>
         </p:txBody>
@@ -4467,8 +4467,8 @@
         </p:nvSpPr>
         <p:spPr>
           <a:xfrm>
-            <a:off x="731520" y="1371600"/>
-            <a:ext cx="10728655" cy="1463040"/>
+            <a:off x="731520" y="1280160"/>
+            <a:ext cx="5257800" cy="2011680"/>
           </a:xfrm>
           <a:prstGeom prst="roundRect">
             <a:avLst/>
@@ -4508,15 +4508,15 @@
               </a:defRPr>
             </a:pPr>
             <a:r>
-              <a:t>OFFICIAL GITHUB REPOSITORY LINK</a:t>
+              <a:t>🐙 OFFICIAL GITHUB REPOSITORY</a:t>
             </a:r>
           </a:p>
           <a:p>
             <a:pPr>
               <a:spcBef>
-                <a:spcPts val="600"/>
+                <a:spcPts val="400"/>
               </a:spcBef>
-              <a:defRPr sz="1800" b="1">
+              <a:defRPr sz="1200" b="1">
                 <a:solidFill>
                   <a:srgbClr val="FFFFFF"/>
                 </a:solidFill>
@@ -4533,12 +4533,16 @@
               </a:spcBef>
               <a:defRPr sz="1000">
                 <a:solidFill>
-                  <a:srgbClr val="B4B9BE"/>
-                </a:solidFill>
-              </a:defRPr>
-            </a:pPr>
-            <a:r>
-              <a:t>Replace &lt;YOUR-USERNAME&gt; with your actual GitHub handle upon repository push.</a:t>
+                  <a:srgbClr val="C8CDD2"/>
+                </a:solidFill>
+              </a:defRPr>
+            </a:pPr>
+            <a:r>
+              <a:t>• Complete production codebase, datasets, and presentation deck.</a:t>
+            </a:r>
+            <a:br/>
+            <a:r>
+              <a:t>• Full Git commit history &amp; structured directory hierarchy.</a:t>
             </a:r>
           </a:p>
         </p:txBody>
@@ -4551,8 +4555,96 @@
         </p:nvSpPr>
         <p:spPr>
           <a:xfrm>
-            <a:off x="731520" y="3017520"/>
-            <a:ext cx="10728655" cy="3108960"/>
+            <a:off x="6199632" y="1280160"/>
+            <a:ext cx="5257800" cy="2011680"/>
+          </a:xfrm>
+          <a:prstGeom prst="roundRect">
+            <a:avLst/>
+          </a:prstGeom>
+          <a:solidFill>
+            <a:srgbClr val="1C1C1C"/>
+          </a:solidFill>
+          <a:ln w="15240">
+            <a:solidFill>
+              <a:srgbClr val="E69500"/>
+            </a:solidFill>
+          </a:ln>
+        </p:spPr>
+        <p:style>
+          <a:lnRef idx="1">
+            <a:schemeClr val="accent1"/>
+          </a:lnRef>
+          <a:fillRef idx="3">
+            <a:schemeClr val="accent1"/>
+          </a:fillRef>
+          <a:effectRef idx="2">
+            <a:schemeClr val="accent1"/>
+          </a:effectRef>
+          <a:fontRef idx="minor">
+            <a:schemeClr val="lt1"/>
+          </a:fontRef>
+        </p:style>
+        <p:txBody>
+          <a:bodyPr rtlCol="0" anchor="ctr" wrap="square"/>
+          <a:lstStyle/>
+          <a:p>
+            <a:pPr algn="ctr">
+              <a:defRPr sz="1100" b="1">
+                <a:solidFill>
+                  <a:srgbClr val="E69500"/>
+                </a:solidFill>
+              </a:defRPr>
+            </a:pPr>
+            <a:r>
+              <a:t>⚡ GOOGLE COLAB INTERACTIVE NOTEBOOK</a:t>
+            </a:r>
+          </a:p>
+          <a:p>
+            <a:pPr>
+              <a:spcBef>
+                <a:spcPts val="400"/>
+              </a:spcBef>
+              <a:defRPr sz="1050" b="1">
+                <a:solidFill>
+                  <a:srgbClr val="FFFFFF"/>
+                </a:solidFill>
+              </a:defRPr>
+            </a:pPr>
+            <a:r>
+              <a:t>https://colab.research.google.com/github/&lt;YOUR-USERNAME&gt;/VOIS-Seasonal-Agriculture-Performance-Analysis/blob/main/notebooks/Seasonal_Agriculture_Performance_Analysis.ipynb</a:t>
+            </a:r>
+          </a:p>
+          <a:p>
+            <a:pPr>
+              <a:spcBef>
+                <a:spcPts val="400"/>
+              </a:spcBef>
+              <a:defRPr sz="1000">
+                <a:solidFill>
+                  <a:srgbClr val="C8CDD2"/>
+                </a:solidFill>
+              </a:defRPr>
+            </a:pPr>
+            <a:r>
+              <a:t>• 1-Click Cloud Execution: Run end-to-end EDA and statistical ANOVA directly in your browser.</a:t>
+            </a:r>
+            <a:br/>
+            <a:r>
+              <a:t>• Zero setup required: Auto-fetches dataset and renders interactive charts.</a:t>
+            </a:r>
+          </a:p>
+        </p:txBody>
+      </p:sp>
+      <p:sp>
+        <p:nvSpPr>
+          <p:cNvPr id="8" name="Rounded Rectangle 7"/>
+          <p:cNvSpPr/>
+          <p:nvPr/>
+        </p:nvSpPr>
+        <p:spPr>
+          <a:xfrm>
+            <a:off x="731520" y="3474720"/>
+            <a:ext cx="10728655" cy="2743200"/>
           </a:xfrm>
           <a:prstGeom prst="roundRect">
             <a:avLst/>
@@ -4592,7 +4684,7 @@
               </a:defRPr>
             </a:pPr>
             <a:r>
-              <a:t>📁 Structured Repository Tree Index</a:t>
+              <a:t>📁 Structured Deliverables &amp; Reproduction Directory Index</a:t>
             </a:r>
           </a:p>
           <a:p>
@@ -4607,7 +4699,7 @@
               </a:defRPr>
             </a:pPr>
             <a:r>
-              <a:t>•  data/           : Contains raw CSV (4,000 records) and cleaned dataset with imputed medians.</a:t>
+              <a:t>•  data/           : Contains raw CSV (4,000 records) and cleaned dataset with stratified median imputation.</a:t>
             </a:r>
           </a:p>
           <a:p>
@@ -4622,7 +4714,7 @@
               </a:defRPr>
             </a:pPr>
             <a:r>
-              <a:t>•  notebooks/      : Seasonal_Agriculture_Performance_Analysis.ipynb - Documented research notebook with ANOVA &amp; visualizations.</a:t>
+              <a:t>•  notebooks/      : Seasonal_Agriculture_Performance_Analysis.ipynb - Google Colab compatible research notebook.</a:t>
             </a:r>
           </a:p>
           <a:p>
@@ -4670,26 +4762,11 @@
               <a:t>•  docs/           : VOIS_Major_Project_Final_Submission.pptx - 14-slide executive submission presentation.</a:t>
             </a:r>
           </a:p>
-          <a:p>
-            <a:pPr>
-              <a:spcBef>
-                <a:spcPts val="200"/>
-              </a:spcBef>
-              <a:defRPr sz="1050">
-                <a:solidFill>
-                  <a:srgbClr val="3C4043"/>
-                </a:solidFill>
-              </a:defRPr>
-            </a:pPr>
-            <a:r>
-              <a:t>•  README.md       : Production-grade project documentation with reproduction instructions.</a:t>
-            </a:r>
-          </a:p>
-        </p:txBody>
-      </p:sp>
-      <p:sp>
-        <p:nvSpPr>
-          <p:cNvPr id="8" name="TextBox 7"/>
+        </p:txBody>
+      </p:sp>
+      <p:sp>
+        <p:nvSpPr>
+          <p:cNvPr id="9" name="TextBox 8"/>
           <p:cNvSpPr txBox="1"/>
           <p:nvPr/>
         </p:nvSpPr>

</xml_diff>

<commit_message>
feat: replace placeholder username with princex100 in Colab links, notebook, PPT and README
</commit_message>
<xml_diff>
--- a/docs/VOIS_Major_Project_Final_Submission.pptx
+++ b/docs/VOIS_Major_Project_Final_Submission.pptx
@@ -4523,7 +4523,7 @@
               </a:defRPr>
             </a:pPr>
             <a:r>
-              <a:t>https://github.com/&lt;YOUR-USERNAME&gt;/VOIS-Seasonal-Agriculture-Performance-Analysis</a:t>
+              <a:t>https://github.com/princex100/VOIS-Seasonal-Agriculture-Performance-Analysis</a:t>
             </a:r>
           </a:p>
           <a:p>
@@ -4611,7 +4611,7 @@
               </a:defRPr>
             </a:pPr>
             <a:r>
-              <a:t>https://colab.research.google.com/github/&lt;YOUR-USERNAME&gt;/VOIS-Seasonal-Agriculture-Performance-Analysis/blob/main/notebooks/Seasonal_Agriculture_Performance_Analysis.ipynb</a:t>
+              <a:t>https://colab.research.google.com/github/princex100/VOIS-Seasonal-Agriculture-Performance-Analysis/blob/main/notebooks/Seasonal_Agriculture_Performance_Analysis.ipynb</a:t>
             </a:r>
           </a:p>
           <a:p>

</xml_diff>